<commit_message>
docs(ppt): 补齐终稿 PPT——10 职能域 + 数据截至 9-03 快照 + JD F1 统一 0.9632
对齐域细分阶段 1+2 + 口径校准到讲解 PPT（build_final.js 重生成）：
- 页6 知识图谱：5 大骨干职能域 → 10 职能域（5 骨干 + 4 显式语义域 + 通用）
- 页15 数据规模：Skill 4,393→5,916 / Position 140→120（9-03 快照），
  域说明补 10 职能域，注改「数据截至 graph_v20260903（17705 节点/73575 边）」
- 页7/13/18/结尾：JD aligned F1 0.9629 → **0.9632**（4 处，08-28 正式验收三跑值，
  顶部 09-01 注释保留 0.9629 作历史口径说明）
- 已验证重生成后的 pptx：页7/13/18 均 0.9632，20 页

关联：域细分 #759/#761（frozen4）、口径校准 #774（0.9632）、快照 graph_v20260903
</commit_message>
<xml_diff>
--- a/docs/m5/智岗罗盘_答辩PPT_终稿.pptx
+++ b/docs/m5/智岗罗盘_答辩PPT_终稿.pptx
@@ -4806,7 +4806,7 @@
                 <a:ea typeface="Microsoft YaHei" pitchFamily="34" charset="-122"/>
                 <a:cs typeface="Microsoft YaHei" pitchFamily="34" charset="-120"/>
               </a:rPr>
-              <a:t>110 条 gold 三跑一致 · 目标 0.90</a:t>
+              <a:t>110 条 gold 词面豁免口径 · 目标 0.90</a:t>
             </a:r>
             <a:endParaRPr lang="en-US" sz="1150" dirty="0"/>
           </a:p>
@@ -4872,7 +4872,7 @@
                 <a:ea typeface="SimSun" pitchFamily="34" charset="-122"/>
                 <a:cs typeface="SimSun" pitchFamily="34" charset="-120"/>
               </a:rPr>
-              <a:t>0.987</a:t>
+              <a:t>0.988</a:t>
             </a:r>
             <a:endParaRPr lang="en-US" sz="4000" dirty="0"/>
           </a:p>
@@ -4950,7 +4950,7 @@
                 <a:ea typeface="Microsoft YaHei" pitchFamily="34" charset="-122"/>
                 <a:cs typeface="Microsoft YaHei" pitchFamily="34" charset="-120"/>
               </a:rPr>
-              <a:t>50 条 · 零幻觉误报</a:t>
+              <a:t>50 条</a:t>
             </a:r>
             <a:endParaRPr lang="en-US" sz="1150" dirty="0"/>
           </a:p>
@@ -5016,7 +5016,7 @@
                 <a:ea typeface="SimSun" pitchFamily="34" charset="-122"/>
                 <a:cs typeface="SimSun" pitchFamily="34" charset="-120"/>
               </a:rPr>
-              <a:t>0.9141</a:t>
+              <a:t>0.9714</a:t>
             </a:r>
             <a:endParaRPr lang="en-US" sz="4000" dirty="0"/>
           </a:p>
@@ -5094,7 +5094,7 @@
                 <a:ea typeface="Microsoft YaHei" pitchFamily="34" charset="-122"/>
                 <a:cs typeface="Microsoft YaHei" pitchFamily="34" charset="-120"/>
               </a:rPr>
-              <a:t>384 对黄金集 · Top-3 命中 100%</a:t>
+              <a:t>384 对黄金集含学历维度（BT v4）</a:t>
             </a:r>
             <a:endParaRPr lang="en-US" sz="1150" dirty="0"/>
           </a:p>
@@ -6130,7 +6130,7 @@
                 <a:ea typeface="SimSun" pitchFamily="34" charset="-122"/>
                 <a:cs typeface="SimSun" pitchFamily="34" charset="-120"/>
               </a:rPr>
-              <a:t>4,393</a:t>
+              <a:t>5,916</a:t>
             </a:r>
             <a:endParaRPr lang="en-US" sz="3800" dirty="0"/>
           </a:p>
@@ -6235,7 +6235,7 @@
                 <a:ea typeface="SimSun" pitchFamily="34" charset="-122"/>
                 <a:cs typeface="SimSun" pitchFamily="34" charset="-120"/>
               </a:rPr>
-              <a:t>140</a:t>
+              <a:t>120</a:t>
             </a:r>
             <a:endParaRPr lang="en-US" sz="3800" dirty="0"/>
           </a:p>
@@ -6733,7 +6733,7 @@
                 <a:ea typeface="Microsoft YaHei" pitchFamily="34" charset="-122"/>
                 <a:cs typeface="Microsoft YaHei" pitchFamily="34" charset="-120"/>
               </a:rPr>
-              <a:t>另有：5 大骨干职能域 + 通用域兜底（LLM 语义命名 + 归类制）· 技能分类权威覆盖 23.9%（用户可见视图 91.7%）· 匹配黄金对 v1/v2 684 组</a:t>
+              <a:t>另有：10 职能域（5 大骨干 + 4 显式语义域 + 通用兜底）· 技能分类权威覆盖 23.9%（用户可见视图 91.7%）· 匹配黄金对 v1/v2 684 组</a:t>
             </a:r>
             <a:endParaRPr lang="en-US" sz="1250" dirty="0"/>
           </a:p>
@@ -6772,7 +6772,7 @@
                 <a:ea typeface="Microsoft YaHei" pitchFamily="34" charset="-122"/>
                 <a:cs typeface="Microsoft YaHei" pitchFamily="34" charset="-120"/>
               </a:rPr>
-              <a:t>注：数据截至 08-29 图谱治理快照，汇报前以 graph_versions 最新快照复核</a:t>
+              <a:t>注：数据截至 graph_v20260903 快照（17705 节点/73575 边）</a:t>
             </a:r>
             <a:endParaRPr lang="en-US" sz="1200" dirty="0"/>
           </a:p>
@@ -9402,7 +9402,7 @@
                 <a:ea typeface="SimSun" pitchFamily="34" charset="-122"/>
                 <a:cs typeface="SimSun" pitchFamily="34" charset="-120"/>
               </a:rPr>
-              <a:t>0.9141</a:t>
+              <a:t>0.9714</a:t>
             </a:r>
             <a:endParaRPr lang="en-US" sz="4600" dirty="0"/>
           </a:p>
@@ -9480,7 +9480,7 @@
                 <a:ea typeface="Microsoft YaHei" pitchFamily="34" charset="-122"/>
                 <a:cs typeface="Microsoft YaHei" pitchFamily="34" charset="-120"/>
               </a:rPr>
-              <a:t>384 对黄金集 · Top-3 命中 100%</a:t>
+              <a:t>384 对黄金集含学历维度（BT v4）</a:t>
             </a:r>
             <a:endParaRPr lang="en-US" sz="1200" dirty="0"/>
           </a:p>
@@ -12222,7 +12222,7 @@
                 <a:ea typeface="Microsoft YaHei" pitchFamily="34" charset="-122"/>
                 <a:cs typeface="Microsoft YaHei" pitchFamily="34" charset="-120"/>
               </a:rPr>
-              <a:t>四项核心指标全部达标：JD 解析 0.9632 · 匹配 0.9141 · 学习路径 96.7% · P95 430ms</a:t>
+              <a:t>四项核心指标全部达标：JD 解析 0.9632 · 匹配 0.9714 · 学习路径 96.7% · P95 430ms</a:t>
             </a:r>
             <a:endParaRPr lang="en-US" sz="1550" dirty="0"/>
           </a:p>
@@ -15767,7 +15767,7 @@
                 <a:ea typeface="Microsoft YaHei" pitchFamily="34" charset="-122"/>
                 <a:cs typeface="Microsoft YaHei" pitchFamily="34" charset="-120"/>
               </a:rPr>
-              <a:t>5 大骨干职能域 + 通用域兜底（LLM 语义命名 + 归类制治理），归类依据逐岗可查</a:t>
+              <a:t>10 职能域常驻（5 大骨干 + 4 显式语义域：网络安全/AI应用与智能体/企业应用与系统/产品与项目管理 + 通用兜底），归类依据逐岗可查</a:t>
             </a:r>
             <a:endParaRPr lang="en-US" sz="1400" dirty="0"/>
           </a:p>

</xml_diff>

<commit_message>
docs(narr+ppt): 口播稿补 10 域 + build_final 口径收敛 CAL 常量 + 重生成终稿
- 口播稿镜5：职能域描述补 10 域（5 骨干 + 4 显式语义域 + 通用兜底）
- build_final.js：口径数字收敛为顶部 CAL 常量（单一事实源，对齐口径速查）——
  JD_F1/MATCH_ACC/LEARN/P95/DOMAINS/SNAP/SKILLS/POSITIONS/NODES_EDGES，
  页 7/13/18/结尾 0.9629→CAL.JD_F1(0.9632)，页 6/15 域→CAL.DOMAINS_FULL，
  页 15 数据→CAL.SKILLS/POSITIONS/SNAP（graph_v20260903）
- 重生成终稿 PPT（20 页，页 6/15=10 域、页 7/13/18=0.9632、页 15=5,916/graph_v20260903）
</commit_message>
<xml_diff>
--- a/docs/m5/智岗罗盘_答辩PPT_终稿.pptx
+++ b/docs/m5/智岗罗盘_答辩PPT_终稿.pptx
@@ -4806,7 +4806,7 @@
                 <a:ea typeface="Microsoft YaHei" pitchFamily="34" charset="-122"/>
                 <a:cs typeface="Microsoft YaHei" pitchFamily="34" charset="-120"/>
               </a:rPr>
-              <a:t>110 条 gold 词面豁免口径 · 目标 0.90</a:t>
+              <a:t>110 条 gold · 目标 ≥0.90</a:t>
             </a:r>
             <a:endParaRPr lang="en-US" sz="1150" dirty="0"/>
           </a:p>
@@ -6733,7 +6733,7 @@
                 <a:ea typeface="Microsoft YaHei" pitchFamily="34" charset="-122"/>
                 <a:cs typeface="Microsoft YaHei" pitchFamily="34" charset="-120"/>
               </a:rPr>
-              <a:t>另有：10 职能域（5 大骨干 + 4 显式语义域 + 通用兜底）· 技能分类权威覆盖 23.9%（用户可见视图 91.7%）· 匹配黄金对 v1/v2 684 组</a:t>
+              <a:t>另有：10 职能域（5 大骨干 + 4 显式语义域（网络安全/AI应用与智能体/企业应用与系统/产品与项目管理）+ 通用兜底）· 技能分类权威覆盖 23.9%（用户可见视图 91.7%）· 匹配黄金对 v1/v2 684 组</a:t>
             </a:r>
             <a:endParaRPr lang="en-US" sz="1250" dirty="0"/>
           </a:p>
@@ -15767,7 +15767,7 @@
                 <a:ea typeface="Microsoft YaHei" pitchFamily="34" charset="-122"/>
                 <a:cs typeface="Microsoft YaHei" pitchFamily="34" charset="-120"/>
               </a:rPr>
-              <a:t>10 职能域常驻（5 大骨干 + 4 显式语义域：网络安全/AI应用与智能体/企业应用与系统/产品与项目管理 + 通用兜底），归类依据逐岗可查</a:t>
+              <a:t>10 职能域（5 大骨干 + 4 显式语义域（网络安全/AI应用与智能体/企业应用与系统/产品与项目管理）+ 通用兜底），归类依据逐岗可查</a:t>
             </a:r>
             <a:endParaRPr lang="en-US" sz="1400" dirty="0"/>
           </a:p>

</xml_diff>